<commit_message>
Refine sidebar and logout UI
</commit_message>
<xml_diff>
--- a/BAHAN/CP Snack Inventory.pptx
+++ b/BAHAN/CP Snack Inventory.pptx
@@ -16,7 +16,8 @@
     <p:sldId id="262" r:id="rId10"/>
     <p:sldId id="263" r:id="rId11"/>
     <p:sldId id="264" r:id="rId12"/>
-    <p:sldId id="267" r:id="rId13"/>
+    <p:sldId id="270" r:id="rId13"/>
+    <p:sldId id="267" r:id="rId14"/>
   </p:sldIdLst>
   <p:sldSz cx="12192000" cy="6858000"/>
   <p:notesSz cx="6858000" cy="9144000"/>
@@ -6032,6 +6033,281 @@
 </file>
 
 <file path=ppt/slides/slide12.xml><?xml version="1.0" encoding="utf-8"?>
+<p:sld xmlns:a="http://schemas.openxmlformats.org/drawingml/2006/main" xmlns:r="http://schemas.openxmlformats.org/officeDocument/2006/relationships" xmlns:p="http://schemas.openxmlformats.org/presentationml/2006/main">
+  <p:cSld>
+    <p:spTree>
+      <p:nvGrpSpPr>
+        <p:cNvPr id="1" name=""/>
+        <p:cNvGrpSpPr/>
+        <p:nvPr/>
+      </p:nvGrpSpPr>
+      <p:grpSpPr>
+        <a:xfrm>
+          <a:off x="0" y="0"/>
+          <a:ext cx="0" cy="0"/>
+          <a:chOff x="0" y="0"/>
+          <a:chExt cx="0" cy="0"/>
+        </a:xfrm>
+      </p:grpSpPr>
+      <p:sp>
+        <p:nvSpPr>
+          <p:cNvPr id="2" name="Rectangle 1"/>
+          <p:cNvSpPr/>
+          <p:nvPr/>
+        </p:nvSpPr>
+        <p:spPr>
+          <a:xfrm>
+            <a:off x="0" y="0"/>
+            <a:ext cx="12191695" cy="6858000"/>
+          </a:xfrm>
+          <a:prstGeom prst="rect">
+            <a:avLst/>
+          </a:prstGeom>
+          <a:solidFill>
+            <a:srgbClr val="F6F9FD"/>
+          </a:solidFill>
+          <a:ln>
+            <a:noFill/>
+          </a:ln>
+        </p:spPr>
+        <p:style>
+          <a:lnRef idx="1">
+            <a:schemeClr val="accent1"/>
+          </a:lnRef>
+          <a:fillRef idx="3">
+            <a:schemeClr val="accent1"/>
+          </a:fillRef>
+          <a:effectRef idx="2">
+            <a:schemeClr val="accent1"/>
+          </a:effectRef>
+          <a:fontRef idx="minor">
+            <a:schemeClr val="lt1"/>
+          </a:fontRef>
+        </p:style>
+        <p:txBody>
+          <a:bodyPr rtlCol="0" anchor="ctr"/>
+          <a:lstStyle/>
+          <a:p>
+            <a:pPr algn="ctr"/>
+            <a:endParaRPr/>
+          </a:p>
+        </p:txBody>
+      </p:sp>
+      <p:sp>
+        <p:nvSpPr>
+          <p:cNvPr id="3" name="Rectangle 2"/>
+          <p:cNvSpPr/>
+          <p:nvPr/>
+        </p:nvSpPr>
+        <p:spPr>
+          <a:xfrm>
+            <a:off x="594360" y="438912"/>
+            <a:ext cx="530352" cy="73152"/>
+          </a:xfrm>
+          <a:prstGeom prst="rect">
+            <a:avLst/>
+          </a:prstGeom>
+          <a:solidFill>
+            <a:srgbClr val="2563EB"/>
+          </a:solidFill>
+          <a:ln>
+            <a:noFill/>
+          </a:ln>
+        </p:spPr>
+        <p:style>
+          <a:lnRef idx="1">
+            <a:schemeClr val="accent1"/>
+          </a:lnRef>
+          <a:fillRef idx="3">
+            <a:schemeClr val="accent1"/>
+          </a:fillRef>
+          <a:effectRef idx="2">
+            <a:schemeClr val="accent1"/>
+          </a:effectRef>
+          <a:fontRef idx="minor">
+            <a:schemeClr val="lt1"/>
+          </a:fontRef>
+        </p:style>
+        <p:txBody>
+          <a:bodyPr rtlCol="0" anchor="ctr"/>
+          <a:lstStyle/>
+          <a:p>
+            <a:pPr algn="ctr"/>
+            <a:endParaRPr/>
+          </a:p>
+        </p:txBody>
+      </p:sp>
+      <p:sp>
+        <p:nvSpPr>
+          <p:cNvPr id="4" name="TextBox 3"/>
+          <p:cNvSpPr txBox="1"/>
+          <p:nvPr/>
+        </p:nvSpPr>
+        <p:spPr>
+          <a:xfrm>
+            <a:off x="594360" y="603504"/>
+            <a:ext cx="10424160" cy="566928"/>
+          </a:xfrm>
+          <a:prstGeom prst="rect">
+            <a:avLst/>
+          </a:prstGeom>
+          <a:noFill/>
+        </p:spPr>
+        <p:txBody>
+          <a:bodyPr wrap="square" anchor="t">
+            <a:spAutoFit/>
+          </a:bodyPr>
+          <a:lstStyle/>
+          <a:p>
+            <a:pPr algn="l">
+              <a:defRPr sz="3000" b="1">
+                <a:solidFill>
+                  <a:srgbClr val="0F172A"/>
+                </a:solidFill>
+              </a:defRPr>
+            </a:pPr>
+            <a:r>
+              <a:rPr lang="en-US" dirty="0"/>
+              <a:t>MOCKUP APP</a:t>
+            </a:r>
+            <a:endParaRPr dirty="0"/>
+          </a:p>
+        </p:txBody>
+      </p:sp>
+      <p:pic>
+        <p:nvPicPr>
+          <p:cNvPr id="6" name="Picture 5">
+            <a:extLst>
+              <a:ext uri="{FF2B5EF4-FFF2-40B4-BE49-F238E27FC236}">
+                <a16:creationId xmlns:a16="http://schemas.microsoft.com/office/drawing/2014/main" id="{B0BF4608-EECA-4F61-832F-20EDBBC0EF0B}"/>
+              </a:ext>
+            </a:extLst>
+          </p:cNvPr>
+          <p:cNvPicPr>
+            <a:picLocks noChangeAspect="1"/>
+          </p:cNvPicPr>
+          <p:nvPr/>
+        </p:nvPicPr>
+        <p:blipFill>
+          <a:blip r:embed="rId2"/>
+          <a:stretch>
+            <a:fillRect/>
+          </a:stretch>
+        </p:blipFill>
+        <p:spPr>
+          <a:xfrm>
+            <a:off x="5885452" y="4306872"/>
+            <a:ext cx="4990580" cy="2351380"/>
+          </a:xfrm>
+          <a:prstGeom prst="rect">
+            <a:avLst/>
+          </a:prstGeom>
+        </p:spPr>
+      </p:pic>
+      <p:pic>
+        <p:nvPicPr>
+          <p:cNvPr id="10" name="Picture 9">
+            <a:extLst>
+              <a:ext uri="{FF2B5EF4-FFF2-40B4-BE49-F238E27FC236}">
+                <a16:creationId xmlns:a16="http://schemas.microsoft.com/office/drawing/2014/main" id="{9B597EF9-974E-48CE-A1B4-7BDEE62CE88F}"/>
+              </a:ext>
+            </a:extLst>
+          </p:cNvPr>
+          <p:cNvPicPr>
+            <a:picLocks noChangeAspect="1"/>
+          </p:cNvPicPr>
+          <p:nvPr/>
+        </p:nvPicPr>
+        <p:blipFill>
+          <a:blip r:embed="rId3"/>
+          <a:stretch>
+            <a:fillRect/>
+          </a:stretch>
+        </p:blipFill>
+        <p:spPr>
+          <a:xfrm>
+            <a:off x="594360" y="1455387"/>
+            <a:ext cx="5193436" cy="2606341"/>
+          </a:xfrm>
+          <a:prstGeom prst="rect">
+            <a:avLst/>
+          </a:prstGeom>
+        </p:spPr>
+      </p:pic>
+      <p:pic>
+        <p:nvPicPr>
+          <p:cNvPr id="14" name="Picture 13">
+            <a:extLst>
+              <a:ext uri="{FF2B5EF4-FFF2-40B4-BE49-F238E27FC236}">
+                <a16:creationId xmlns:a16="http://schemas.microsoft.com/office/drawing/2014/main" id="{CA19695B-1106-447E-BE1E-82B1A72C658E}"/>
+              </a:ext>
+            </a:extLst>
+          </p:cNvPr>
+          <p:cNvPicPr>
+            <a:picLocks noChangeAspect="1"/>
+          </p:cNvPicPr>
+          <p:nvPr/>
+        </p:nvPicPr>
+        <p:blipFill>
+          <a:blip r:embed="rId4"/>
+          <a:stretch>
+            <a:fillRect/>
+          </a:stretch>
+        </p:blipFill>
+        <p:spPr>
+          <a:xfrm>
+            <a:off x="594361" y="4120854"/>
+            <a:ext cx="5193436" cy="2466376"/>
+          </a:xfrm>
+          <a:prstGeom prst="rect">
+            <a:avLst/>
+          </a:prstGeom>
+        </p:spPr>
+      </p:pic>
+      <p:pic>
+        <p:nvPicPr>
+          <p:cNvPr id="16" name="Picture 15">
+            <a:extLst>
+              <a:ext uri="{FF2B5EF4-FFF2-40B4-BE49-F238E27FC236}">
+                <a16:creationId xmlns:a16="http://schemas.microsoft.com/office/drawing/2014/main" id="{4AEB7321-62BC-44F6-A339-18293339A3E3}"/>
+              </a:ext>
+            </a:extLst>
+          </p:cNvPr>
+          <p:cNvPicPr>
+            <a:picLocks noChangeAspect="1"/>
+          </p:cNvPicPr>
+          <p:nvPr/>
+        </p:nvPicPr>
+        <p:blipFill>
+          <a:blip r:embed="rId5"/>
+          <a:stretch>
+            <a:fillRect/>
+          </a:stretch>
+        </p:blipFill>
+        <p:spPr>
+          <a:xfrm>
+            <a:off x="5885452" y="1455387"/>
+            <a:ext cx="4990580" cy="2652345"/>
+          </a:xfrm>
+          <a:prstGeom prst="rect">
+            <a:avLst/>
+          </a:prstGeom>
+        </p:spPr>
+      </p:pic>
+    </p:spTree>
+    <p:extLst>
+      <p:ext uri="{BB962C8B-B14F-4D97-AF65-F5344CB8AC3E}">
+        <p14:creationId xmlns:p14="http://schemas.microsoft.com/office/powerpoint/2010/main" val="4109238983"/>
+      </p:ext>
+    </p:extLst>
+  </p:cSld>
+  <p:clrMapOvr>
+    <a:masterClrMapping/>
+  </p:clrMapOvr>
+</p:sld>
+</file>
+
+<file path=ppt/slides/slide13.xml><?xml version="1.0" encoding="utf-8"?>
 <p:sld xmlns:a="http://schemas.openxmlformats.org/drawingml/2006/main" xmlns:r="http://schemas.openxmlformats.org/officeDocument/2006/relationships" xmlns:p="http://schemas.openxmlformats.org/presentationml/2006/main">
   <p:cSld>
     <p:spTree>

</xml_diff>